<commit_message>
Adding PDF report and PPTX
</commit_message>
<xml_diff>
--- a/Presentación Skin Diseases.pptx
+++ b/Presentación Skin Diseases.pptx
@@ -1997,7 +1997,7 @@
       </dgm:t>
     </dgm:pt>
     <dgm:pt modelId="{85BD18C9-7113-4685-9857-18C56F53E183}">
-      <dgm:prSet phldrT="[Texto]"/>
+      <dgm:prSet phldrT="[Texto]" custT="1"/>
       <dgm:spPr/>
       <dgm:t>
         <a:bodyPr/>
@@ -2007,11 +2007,11 @@
             <a:buNone/>
           </a:pPr>
           <a:r>
-            <a:rPr lang="es-MX" b="1" dirty="0"/>
+            <a:rPr lang="es-MX" sz="2000" b="1" dirty="0"/>
             <a:t>Etapa 1:</a:t>
           </a:r>
           <a:r>
-            <a:rPr lang="es-MX" dirty="0"/>
+            <a:rPr lang="es-MX" sz="2000" dirty="0"/>
             <a:t> Modelo Base - solo metadatos.</a:t>
           </a:r>
         </a:p>
@@ -2055,8 +2055,13 @@
           </a:r>
           <a:r>
             <a:rPr lang="es-MX" dirty="0"/>
-            <a:t> Exploración Profunda con CNN y redes secuenciales LSTM/GRU</a:t>
+            <a:t> </a:t>
           </a:r>
+          <a:r>
+            <a:rPr lang="es-SV" dirty="0"/>
+            <a:t>ARQUITECTURA PROFUNDA ESPECIALIZADA</a:t>
+          </a:r>
+          <a:endParaRPr lang="es-MX" dirty="0"/>
         </a:p>
       </dgm:t>
     </dgm:pt>
@@ -2098,16 +2103,13 @@
           </a:r>
           <a:r>
             <a:rPr lang="es-MX" dirty="0"/>
-            <a:t> Transfer </a:t>
+            <a:t> </a:t>
           </a:r>
           <a:r>
-            <a:rPr lang="es-MX" dirty="0" err="1"/>
-            <a:t>Learning</a:t>
+            <a:rPr lang="es-SV" dirty="0"/>
+            <a:t>MODELOS PREENTRENADOS Y TRANSFORMERS</a:t>
           </a:r>
-          <a:r>
-            <a:rPr lang="es-MX" dirty="0"/>
-            <a:t> EfficientNetB0 para procesamiento de imágenes.</a:t>
-          </a:r>
+          <a:endParaRPr lang="es-MX" dirty="0"/>
         </a:p>
       </dgm:t>
     </dgm:pt>
@@ -2149,16 +2151,13 @@
           </a:r>
           <a:r>
             <a:rPr lang="es-MX" dirty="0"/>
-            <a:t> Modelado Generativo </a:t>
+            <a:t> </a:t>
           </a:r>
           <a:r>
-            <a:rPr lang="es-MX" dirty="0" err="1"/>
-            <a:t>Autoencoder</a:t>
+            <a:rPr lang="es-SV" dirty="0"/>
+            <a:t>COMPONENTE GENERATIVO Y AUMENTO SINTÉTICO</a:t>
           </a:r>
-          <a:r>
-            <a:rPr lang="es-MX" dirty="0"/>
-            <a:t> para mejora de calidad</a:t>
-          </a:r>
+          <a:endParaRPr lang="es-MX" dirty="0"/>
         </a:p>
       </dgm:t>
     </dgm:pt>
@@ -2253,7 +2252,7 @@
       <dgm:spPr/>
     </dgm:pt>
     <dgm:pt modelId="{F1D28828-56D6-4414-9085-84A43B2F59B1}" type="pres">
-      <dgm:prSet presAssocID="{E09DBC38-53E1-4BC9-A923-E651E474A28E}" presName="FiveNodes_1" presStyleLbl="node1" presStyleIdx="0" presStyleCnt="5">
+      <dgm:prSet presAssocID="{E09DBC38-53E1-4BC9-A923-E651E474A28E}" presName="FiveNodes_1" presStyleLbl="node1" presStyleIdx="0" presStyleCnt="5" custLinFactNeighborX="2">
         <dgm:presLayoutVars>
           <dgm:bulletEnabled val="1"/>
         </dgm:presLayoutVars>
@@ -3032,7 +3031,7 @@
       </dsp:nvSpPr>
       <dsp:spPr>
         <a:xfrm>
-          <a:off x="0" y="0"/>
+          <a:off x="172" y="0"/>
           <a:ext cx="8605170" cy="666981"/>
         </a:xfrm>
         <a:prstGeom prst="roundRect">
@@ -3076,12 +3075,12 @@
         </a:fontRef>
       </dsp:style>
       <dsp:txBody>
-        <a:bodyPr spcFirstLastPara="0" vert="horz" wrap="square" lIns="68580" tIns="68580" rIns="68580" bIns="68580" numCol="1" spcCol="1270" anchor="ctr" anchorCtr="0">
+        <a:bodyPr spcFirstLastPara="0" vert="horz" wrap="square" lIns="76200" tIns="76200" rIns="76200" bIns="76200" numCol="1" spcCol="1270" anchor="ctr" anchorCtr="0">
           <a:noAutofit/>
         </a:bodyPr>
         <a:lstStyle/>
         <a:p>
-          <a:pPr marL="0" lvl="0" indent="0" algn="l" defTabSz="800100">
+          <a:pPr marL="0" lvl="0" indent="0" algn="l" defTabSz="889000">
             <a:lnSpc>
               <a:spcPct val="90000"/>
             </a:lnSpc>
@@ -3094,17 +3093,17 @@
             <a:buNone/>
           </a:pPr>
           <a:r>
-            <a:rPr lang="es-MX" sz="1800" b="1" kern="1200" dirty="0"/>
+            <a:rPr lang="es-MX" sz="2000" b="1" kern="1200" dirty="0"/>
             <a:t>Etapa 1:</a:t>
           </a:r>
           <a:r>
-            <a:rPr lang="es-MX" sz="1800" kern="1200" dirty="0"/>
+            <a:rPr lang="es-MX" sz="2000" kern="1200" dirty="0"/>
             <a:t> Modelo Base - solo metadatos.</a:t>
           </a:r>
         </a:p>
       </dsp:txBody>
       <dsp:txXfrm>
-        <a:off x="19535" y="19535"/>
+        <a:off x="19707" y="19535"/>
         <a:ext cx="7807409" cy="627911"/>
       </dsp:txXfrm>
     </dsp:sp>
@@ -3159,12 +3158,12 @@
         </a:fontRef>
       </dsp:style>
       <dsp:txBody>
-        <a:bodyPr spcFirstLastPara="0" vert="horz" wrap="square" lIns="68580" tIns="68580" rIns="68580" bIns="68580" numCol="1" spcCol="1270" anchor="ctr" anchorCtr="0">
+        <a:bodyPr spcFirstLastPara="0" vert="horz" wrap="square" lIns="76200" tIns="76200" rIns="76200" bIns="76200" numCol="1" spcCol="1270" anchor="ctr" anchorCtr="0">
           <a:noAutofit/>
         </a:bodyPr>
         <a:lstStyle/>
         <a:p>
-          <a:pPr marL="0" lvl="0" indent="0" algn="l" defTabSz="800100">
+          <a:pPr marL="0" lvl="0" indent="0" algn="l" defTabSz="889000">
             <a:lnSpc>
               <a:spcPct val="90000"/>
             </a:lnSpc>
@@ -3177,13 +3176,18 @@
             <a:buNone/>
           </a:pPr>
           <a:r>
-            <a:rPr lang="es-MX" sz="1800" b="1" kern="1200" dirty="0"/>
+            <a:rPr lang="es-MX" sz="2000" b="1" kern="1200" dirty="0"/>
             <a:t>Etapa 2:</a:t>
           </a:r>
           <a:r>
-            <a:rPr lang="es-MX" sz="1800" kern="1200" dirty="0"/>
-            <a:t> Exploración Profunda con CNN y redes secuenciales LSTM/GRU</a:t>
+            <a:rPr lang="es-MX" sz="2000" kern="1200" dirty="0"/>
+            <a:t> </a:t>
           </a:r>
+          <a:r>
+            <a:rPr lang="es-SV" sz="2000" kern="1200" dirty="0"/>
+            <a:t>ARQUITECTURA PROFUNDA ESPECIALIZADA</a:t>
+          </a:r>
+          <a:endParaRPr lang="es-MX" sz="2000" kern="1200" dirty="0"/>
         </a:p>
       </dsp:txBody>
       <dsp:txXfrm>
@@ -3242,12 +3246,12 @@
         </a:fontRef>
       </dsp:style>
       <dsp:txBody>
-        <a:bodyPr spcFirstLastPara="0" vert="horz" wrap="square" lIns="68580" tIns="68580" rIns="68580" bIns="68580" numCol="1" spcCol="1270" anchor="ctr" anchorCtr="0">
+        <a:bodyPr spcFirstLastPara="0" vert="horz" wrap="square" lIns="76200" tIns="76200" rIns="76200" bIns="76200" numCol="1" spcCol="1270" anchor="ctr" anchorCtr="0">
           <a:noAutofit/>
         </a:bodyPr>
         <a:lstStyle/>
         <a:p>
-          <a:pPr marL="0" lvl="0" indent="0" algn="l" defTabSz="800100">
+          <a:pPr marL="0" lvl="0" indent="0" algn="l" defTabSz="889000">
             <a:lnSpc>
               <a:spcPct val="90000"/>
             </a:lnSpc>
@@ -3260,21 +3264,18 @@
             <a:buNone/>
           </a:pPr>
           <a:r>
-            <a:rPr lang="es-MX" sz="1800" b="1" kern="1200" dirty="0"/>
+            <a:rPr lang="es-MX" sz="2000" b="1" kern="1200" dirty="0"/>
             <a:t>Etapa 3:</a:t>
           </a:r>
           <a:r>
-            <a:rPr lang="es-MX" sz="1800" kern="1200" dirty="0"/>
-            <a:t> Transfer </a:t>
+            <a:rPr lang="es-MX" sz="2000" kern="1200" dirty="0"/>
+            <a:t> </a:t>
           </a:r>
           <a:r>
-            <a:rPr lang="es-MX" sz="1800" kern="1200" dirty="0" err="1"/>
-            <a:t>Learning</a:t>
+            <a:rPr lang="es-SV" sz="2000" kern="1200" dirty="0"/>
+            <a:t>MODELOS PREENTRENADOS Y TRANSFORMERS</a:t>
           </a:r>
-          <a:r>
-            <a:rPr lang="es-MX" sz="1800" kern="1200" dirty="0"/>
-            <a:t> EfficientNetB0 para procesamiento de imágenes.</a:t>
-          </a:r>
+          <a:endParaRPr lang="es-MX" sz="2000" kern="1200" dirty="0"/>
         </a:p>
       </dsp:txBody>
       <dsp:txXfrm>
@@ -3333,12 +3334,12 @@
         </a:fontRef>
       </dsp:style>
       <dsp:txBody>
-        <a:bodyPr spcFirstLastPara="0" vert="horz" wrap="square" lIns="68580" tIns="68580" rIns="68580" bIns="68580" numCol="1" spcCol="1270" anchor="ctr" anchorCtr="0">
+        <a:bodyPr spcFirstLastPara="0" vert="horz" wrap="square" lIns="76200" tIns="76200" rIns="76200" bIns="76200" numCol="1" spcCol="1270" anchor="ctr" anchorCtr="0">
           <a:noAutofit/>
         </a:bodyPr>
         <a:lstStyle/>
         <a:p>
-          <a:pPr marL="0" lvl="0" indent="0" algn="l" defTabSz="800100">
+          <a:pPr marL="0" lvl="0" indent="0" algn="l" defTabSz="889000">
             <a:lnSpc>
               <a:spcPct val="90000"/>
             </a:lnSpc>
@@ -3351,21 +3352,18 @@
             <a:buNone/>
           </a:pPr>
           <a:r>
-            <a:rPr lang="es-MX" sz="1800" b="1" kern="1200" dirty="0"/>
+            <a:rPr lang="es-MX" sz="2000" b="1" kern="1200" dirty="0"/>
             <a:t>Etapa 4:</a:t>
           </a:r>
           <a:r>
-            <a:rPr lang="es-MX" sz="1800" kern="1200" dirty="0"/>
-            <a:t> Modelado Generativo </a:t>
+            <a:rPr lang="es-MX" sz="2000" kern="1200" dirty="0"/>
+            <a:t> </a:t>
           </a:r>
           <a:r>
-            <a:rPr lang="es-MX" sz="1800" kern="1200" dirty="0" err="1"/>
-            <a:t>Autoencoder</a:t>
+            <a:rPr lang="es-SV" sz="2000" kern="1200" dirty="0"/>
+            <a:t>COMPONENTE GENERATIVO Y AUMENTO SINTÉTICO</a:t>
           </a:r>
-          <a:r>
-            <a:rPr lang="es-MX" sz="1800" kern="1200" dirty="0"/>
-            <a:t> para mejora de calidad</a:t>
-          </a:r>
+          <a:endParaRPr lang="es-MX" sz="2000" kern="1200" dirty="0"/>
         </a:p>
       </dsp:txBody>
       <dsp:txXfrm>
@@ -3424,12 +3422,12 @@
         </a:fontRef>
       </dsp:style>
       <dsp:txBody>
-        <a:bodyPr spcFirstLastPara="0" vert="horz" wrap="square" lIns="68580" tIns="68580" rIns="68580" bIns="68580" numCol="1" spcCol="1270" anchor="ctr" anchorCtr="0">
+        <a:bodyPr spcFirstLastPara="0" vert="horz" wrap="square" lIns="76200" tIns="76200" rIns="76200" bIns="76200" numCol="1" spcCol="1270" anchor="ctr" anchorCtr="0">
           <a:noAutofit/>
         </a:bodyPr>
         <a:lstStyle/>
         <a:p>
-          <a:pPr marL="0" lvl="0" indent="0" algn="l" defTabSz="800100">
+          <a:pPr marL="0" lvl="0" indent="0" algn="l" defTabSz="889000">
             <a:lnSpc>
               <a:spcPct val="90000"/>
             </a:lnSpc>
@@ -3442,22 +3440,22 @@
             <a:buNone/>
           </a:pPr>
           <a:r>
-            <a:rPr lang="es-MX" sz="1800" b="1" i="0" kern="1200" dirty="0"/>
+            <a:rPr lang="es-MX" sz="2000" b="1" i="0" kern="1200" dirty="0"/>
             <a:t>Etapa 5: Fine-</a:t>
           </a:r>
           <a:r>
-            <a:rPr lang="es-MX" sz="1800" b="1" i="0" kern="1200" dirty="0" err="1"/>
+            <a:rPr lang="es-MX" sz="2000" b="1" i="0" kern="1200" dirty="0" err="1"/>
             <a:t>Tuning</a:t>
           </a:r>
           <a:r>
-            <a:rPr lang="es-MX" sz="1800" b="1" i="0" kern="1200" dirty="0"/>
+            <a:rPr lang="es-MX" sz="2000" b="1" i="0" kern="1200" dirty="0"/>
             <a:t> y Despliegue</a:t>
           </a:r>
           <a:r>
-            <a:rPr lang="es-MX" sz="1800" b="0" i="0" kern="1200" dirty="0"/>
+            <a:rPr lang="es-MX" sz="2000" b="0" i="0" kern="1200" dirty="0"/>
             <a:t> </a:t>
           </a:r>
-          <a:endParaRPr lang="es-MX" sz="1800" kern="1200" dirty="0"/>
+          <a:endParaRPr lang="es-MX" sz="2000" kern="1200" dirty="0"/>
         </a:p>
       </dsp:txBody>
       <dsp:txXfrm>
@@ -8401,7 +8399,7 @@
             <a:pPr rtl="0"/>
             <a:fld id="{C62B80FE-187A-4085-BD71-F0873FF7BD68}" type="datetime1">
               <a:rPr lang="es-ES" smtClean="0"/>
-              <a:t>18/04/2026</a:t>
+              <a:t>20/04/2026</a:t>
             </a:fld>
             <a:endParaRPr lang="es-ES"/>
           </a:p>
@@ -8583,7 +8581,7 @@
             <a:pPr rtl="0"/>
             <a:fld id="{6D59A2BD-4571-4110-BB3E-5D004DE434FA}" type="datetime1">
               <a:rPr lang="es-ES" noProof="0" smtClean="0"/>
-              <a:t>18/04/2026</a:t>
+              <a:t>20/04/2026</a:t>
             </a:fld>
             <a:endParaRPr lang="es-ES" noProof="0"/>
           </a:p>
@@ -9387,7 +9385,7 @@
             <a:pPr rtl="0"/>
             <a:fld id="{F409C0D2-15DE-4FAC-845B-C48979FFAEB9}" type="datetime1">
               <a:rPr lang="es-ES" noProof="0" smtClean="0"/>
-              <a:t>18/04/2026</a:t>
+              <a:t>20/04/2026</a:t>
             </a:fld>
             <a:endParaRPr lang="es-ES" noProof="0"/>
           </a:p>
@@ -9652,7 +9650,7 @@
             <a:pPr rtl="0"/>
             <a:fld id="{8CF9F163-DD03-4353-882E-CE0F9A80F1C3}" type="datetime1">
               <a:rPr lang="es-ES" noProof="0" smtClean="0"/>
-              <a:t>18/04/2026</a:t>
+              <a:t>20/04/2026</a:t>
             </a:fld>
             <a:endParaRPr lang="es-ES" noProof="0"/>
           </a:p>
@@ -9890,7 +9888,7 @@
             <a:pPr rtl="0"/>
             <a:fld id="{8D2FF54C-EA2F-453C-857C-5C9ADB86CB43}" type="datetime1">
               <a:rPr lang="es-ES" noProof="0" smtClean="0"/>
-              <a:t>18/04/2026</a:t>
+              <a:t>20/04/2026</a:t>
             </a:fld>
             <a:endParaRPr lang="es-ES" noProof="0"/>
           </a:p>
@@ -10140,7 +10138,7 @@
             <a:pPr rtl="0"/>
             <a:fld id="{57670FF6-52DC-429F-9C56-6A1BF295232E}" type="datetime1">
               <a:rPr lang="es-ES" noProof="0" smtClean="0"/>
-              <a:t>18/04/2026</a:t>
+              <a:t>20/04/2026</a:t>
             </a:fld>
             <a:endParaRPr lang="es-ES" noProof="0"/>
           </a:p>
@@ -10451,7 +10449,7 @@
             <a:pPr rtl="0"/>
             <a:fld id="{85E27922-51B6-4B96-9C28-2CD2060AE75A}" type="datetime1">
               <a:rPr lang="es-ES" noProof="0" smtClean="0"/>
-              <a:t>18/04/2026</a:t>
+              <a:t>20/04/2026</a:t>
             </a:fld>
             <a:endParaRPr lang="es-ES" noProof="0"/>
           </a:p>
@@ -10762,7 +10760,7 @@
             <a:pPr rtl="0"/>
             <a:fld id="{F3ECF5D1-1C98-40FD-9D65-EED7644802B9}" type="datetime1">
               <a:rPr lang="es-ES" noProof="0" smtClean="0"/>
-              <a:t>18/04/2026</a:t>
+              <a:t>20/04/2026</a:t>
             </a:fld>
             <a:endParaRPr lang="es-ES" noProof="0"/>
           </a:p>
@@ -11186,7 +11184,7 @@
             <a:pPr rtl="0"/>
             <a:fld id="{8556C746-EB55-4634-AD93-A9FF2473885C}" type="datetime1">
               <a:rPr lang="es-ES" noProof="0" smtClean="0"/>
-              <a:t>18/04/2026</a:t>
+              <a:t>20/04/2026</a:t>
             </a:fld>
             <a:endParaRPr lang="es-ES" noProof="0"/>
           </a:p>
@@ -11285,7 +11283,7 @@
             <a:pPr rtl="0"/>
             <a:fld id="{C9051F13-F75A-440F-BED7-E2004746A95F}" type="datetime1">
               <a:rPr lang="es-ES" noProof="0" smtClean="0"/>
-              <a:t>18/04/2026</a:t>
+              <a:t>20/04/2026</a:t>
             </a:fld>
             <a:endParaRPr lang="es-ES" noProof="0"/>
           </a:p>
@@ -11451,7 +11449,7 @@
             <a:pPr rtl="0"/>
             <a:fld id="{3D7A2E7D-666A-420B-9042-959E1D47E21D}" type="datetime1">
               <a:rPr lang="es-ES" noProof="0" smtClean="0"/>
-              <a:t>18/04/2026</a:t>
+              <a:t>20/04/2026</a:t>
             </a:fld>
             <a:endParaRPr lang="es-ES" noProof="0"/>
           </a:p>
@@ -11832,7 +11830,7 @@
             <a:pPr rtl="0"/>
             <a:fld id="{0403F12F-0E67-4CAB-8DFD-26DCD4A99D59}" type="datetime1">
               <a:rPr lang="es-ES" noProof="0" smtClean="0"/>
-              <a:t>18/04/2026</a:t>
+              <a:t>20/04/2026</a:t>
             </a:fld>
             <a:endParaRPr lang="es-ES" noProof="0"/>
           </a:p>
@@ -12125,7 +12123,7 @@
             <a:pPr rtl="0"/>
             <a:fld id="{9709DA8C-1A59-4B91-B9EA-509377CD0E23}" type="datetime1">
               <a:rPr lang="es-ES" noProof="0" smtClean="0"/>
-              <a:t>18/04/2026</a:t>
+              <a:t>20/04/2026</a:t>
             </a:fld>
             <a:endParaRPr lang="es-ES" noProof="0"/>
           </a:p>
@@ -12339,7 +12337,7 @@
             <a:pPr rtl="0"/>
             <a:fld id="{A3DF7BF2-42BB-439B-88AA-F60334FF1291}" type="datetime1">
               <a:rPr lang="es-ES" noProof="0" smtClean="0"/>
-              <a:t>18/04/2026</a:t>
+              <a:t>20/04/2026</a:t>
             </a:fld>
             <a:endParaRPr lang="es-ES" noProof="0"/>
           </a:p>
@@ -13498,48 +13496,11 @@
           <a:p>
             <a:r>
               <a:rPr lang="es-MX" dirty="0"/>
-              <a:t>Etapa 4: Mejora de Calidad </a:t>
+              <a:t>ETAPA 4: COMPONENTE GENERATIVO Y AUMENTO SINTÉTICO</a:t>
             </a:r>
-            <a:r>
-              <a:rPr lang="es-MX" dirty="0" err="1"/>
-              <a:t>Denoising</a:t>
-            </a:r>
-            <a:endParaRPr lang="es-MX" dirty="0"/>
           </a:p>
         </p:txBody>
       </p:sp>
-      <p:pic>
-        <p:nvPicPr>
-          <p:cNvPr id="7" name="Marcador de contenido 6">
-            <a:extLst>
-              <a:ext uri="{FF2B5EF4-FFF2-40B4-BE49-F238E27FC236}">
-                <a16:creationId xmlns:a16="http://schemas.microsoft.com/office/drawing/2014/main" id="{4CDC45D3-7A6D-0C48-E624-7F24230235A0}"/>
-              </a:ext>
-            </a:extLst>
-          </p:cNvPr>
-          <p:cNvPicPr>
-            <a:picLocks noGrp="1" noChangeAspect="1"/>
-          </p:cNvPicPr>
-          <p:nvPr>
-            <p:ph sz="half" idx="2"/>
-          </p:nvPr>
-        </p:nvPicPr>
-        <p:blipFill>
-          <a:blip r:embed="rId2"/>
-          <a:stretch>
-            <a:fillRect/>
-          </a:stretch>
-        </p:blipFill>
-        <p:spPr>
-          <a:xfrm>
-            <a:off x="5306331" y="1888686"/>
-            <a:ext cx="6472011" cy="2637953"/>
-          </a:xfrm>
-          <a:prstGeom prst="rect">
-            <a:avLst/>
-          </a:prstGeom>
-        </p:spPr>
-      </p:pic>
       <p:sp>
         <p:nvSpPr>
           <p:cNvPr id="5" name="Rectangle 1">
@@ -13558,8 +13519,8 @@
         </p:nvSpPr>
         <p:spPr bwMode="auto">
           <a:xfrm>
-            <a:off x="303493" y="1888686"/>
-            <a:ext cx="4518878" cy="4190314"/>
+            <a:off x="284443" y="1966628"/>
+            <a:ext cx="4518878" cy="4651979"/>
           </a:xfrm>
           <a:prstGeom prst="rect">
             <a:avLst/>
@@ -13647,7 +13608,7 @@
                 <a:effectLst/>
                 <a:latin typeface="Arial" panose="020B0604020202020204" pitchFamily="34" charset="0"/>
               </a:rPr>
-              <a:t> Red generativa </a:t>
+              <a:t> Se evaluó si el uso de datos sintéticos generados con VAE, </a:t>
             </a:r>
             <a:r>
               <a:rPr kumimoji="0" lang="es-MX" altLang="es-MX" sz="2000" b="0" i="0" u="none" strike="noStrike" cap="none" normalizeH="0" baseline="0" dirty="0" err="1">
@@ -13660,7 +13621,33 @@
                 <a:effectLst/>
                 <a:latin typeface="Arial" panose="020B0604020202020204" pitchFamily="34" charset="0"/>
               </a:rPr>
-              <a:t>Denoising</a:t>
+              <a:t>cGAN</a:t>
+            </a:r>
+            <a:r>
+              <a:rPr kumimoji="0" lang="es-MX" altLang="es-MX" sz="2000" b="0" i="0" u="none" strike="noStrike" cap="none" normalizeH="0" baseline="0" dirty="0">
+                <a:ln>
+                  <a:noFill/>
+                </a:ln>
+                <a:solidFill>
+                  <a:schemeClr val="tx1"/>
+                </a:solidFill>
+                <a:effectLst/>
+                <a:latin typeface="Arial" panose="020B0604020202020204" pitchFamily="34" charset="0"/>
+              </a:rPr>
+              <a:t> y </a:t>
+            </a:r>
+            <a:r>
+              <a:rPr kumimoji="0" lang="es-MX" altLang="es-MX" sz="2000" b="0" i="0" u="none" strike="noStrike" cap="none" normalizeH="0" baseline="0" dirty="0" err="1">
+                <a:ln>
+                  <a:noFill/>
+                </a:ln>
+                <a:solidFill>
+                  <a:schemeClr val="tx1"/>
+                </a:solidFill>
+                <a:effectLst/>
+                <a:latin typeface="Arial" panose="020B0604020202020204" pitchFamily="34" charset="0"/>
+              </a:rPr>
+              <a:t>Stable</a:t>
             </a:r>
             <a:r>
               <a:rPr kumimoji="0" lang="es-MX" altLang="es-MX" sz="2000" b="0" i="0" u="none" strike="noStrike" cap="none" normalizeH="0" baseline="0" dirty="0">
@@ -13686,7 +13673,7 @@
                 <a:effectLst/>
                 <a:latin typeface="Arial" panose="020B0604020202020204" pitchFamily="34" charset="0"/>
               </a:rPr>
-              <a:t>Autoencoder</a:t>
+              <a:t>Diffusion</a:t>
             </a:r>
             <a:r>
               <a:rPr kumimoji="0" lang="es-MX" altLang="es-MX" sz="2000" b="0" i="0" u="none" strike="noStrike" cap="none" normalizeH="0" baseline="0" dirty="0">
@@ -13699,7 +13686,7 @@
                 <a:effectLst/>
                 <a:latin typeface="Arial" panose="020B0604020202020204" pitchFamily="34" charset="0"/>
               </a:rPr>
-              <a:t> diseñada para reconstruir imágenes y eliminar "ruido" antes de la clasificación.</a:t>
+              <a:t> podía mejorar la clasificación dermatológica multiclase en clases desbalanceadas.</a:t>
             </a:r>
           </a:p>
           <a:p>
@@ -13743,36 +13730,63 @@
                 <a:effectLst/>
                 <a:latin typeface="Arial" panose="020B0604020202020204" pitchFamily="34" charset="0"/>
               </a:rPr>
-              <a:t> Aumento de la robustez del sistema frente a imágenes borrosas o de mala calidad, estandarizando la entrada para el modelo EfficientNetB0.</a:t>
+              <a:t> Los escenarios con aumento generativo no mejoraron al </a:t>
+            </a:r>
+            <a:r>
+              <a:rPr kumimoji="0" lang="es-MX" altLang="es-MX" sz="2000" b="0" i="0" u="none" strike="noStrike" cap="none" normalizeH="0" baseline="0" dirty="0" err="1">
+                <a:ln>
+                  <a:noFill/>
+                </a:ln>
+                <a:solidFill>
+                  <a:schemeClr val="tx1"/>
+                </a:solidFill>
+                <a:effectLst/>
+                <a:latin typeface="Arial" panose="020B0604020202020204" pitchFamily="34" charset="0"/>
+              </a:rPr>
+              <a:t>baseline</a:t>
+            </a:r>
+            <a:r>
+              <a:rPr kumimoji="0" lang="es-MX" altLang="es-MX" sz="2000" b="0" i="0" u="none" strike="noStrike" cap="none" normalizeH="0" baseline="0" dirty="0">
+                <a:ln>
+                  <a:noFill/>
+                </a:ln>
+                <a:solidFill>
+                  <a:schemeClr val="tx1"/>
+                </a:solidFill>
+                <a:effectLst/>
+                <a:latin typeface="Arial" panose="020B0604020202020204" pitchFamily="34" charset="0"/>
+              </a:rPr>
+              <a:t>. El mejor desempeño siguió siendo el modelo base sin síntesis, con Macro F1 = 0.6044.</a:t>
             </a:r>
           </a:p>
         </p:txBody>
       </p:sp>
       <p:pic>
         <p:nvPicPr>
-          <p:cNvPr id="9" name="Imagen 8">
+          <p:cNvPr id="8" name="Marcador de contenido 7">
             <a:extLst>
               <a:ext uri="{FF2B5EF4-FFF2-40B4-BE49-F238E27FC236}">
-                <a16:creationId xmlns:a16="http://schemas.microsoft.com/office/drawing/2014/main" id="{FC41E29C-1522-A847-BBAF-A1D3E542F8D4}"/>
+                <a16:creationId xmlns:a16="http://schemas.microsoft.com/office/drawing/2014/main" id="{CE72B475-2BDB-970E-425A-7CCE73A052A5}"/>
               </a:ext>
             </a:extLst>
           </p:cNvPr>
           <p:cNvPicPr>
-            <a:picLocks noChangeAspect="1"/>
+            <a:picLocks noGrp="1" noChangeAspect="1"/>
           </p:cNvPicPr>
-          <p:nvPr/>
+          <p:nvPr>
+            <p:ph sz="half" idx="2"/>
+          </p:nvPr>
         </p:nvPicPr>
         <p:blipFill>
-          <a:blip r:embed="rId3"/>
-          <a:srcRect b="48209"/>
+          <a:blip r:embed="rId2"/>
           <a:stretch>
             <a:fillRect/>
           </a:stretch>
         </p:blipFill>
         <p:spPr>
           <a:xfrm>
-            <a:off x="5306331" y="4526639"/>
-            <a:ext cx="6472011" cy="1601703"/>
+            <a:off x="4883910" y="2303498"/>
+            <a:ext cx="7160827" cy="3978237"/>
           </a:xfrm>
           <a:prstGeom prst="rect">
             <a:avLst/>
@@ -14615,10 +14629,10 @@
       </p:sp>
       <p:pic>
         <p:nvPicPr>
-          <p:cNvPr id="18" name="Marcador de contenido 17">
+          <p:cNvPr id="11" name="Marcador de contenido 10">
             <a:extLst>
               <a:ext uri="{FF2B5EF4-FFF2-40B4-BE49-F238E27FC236}">
-                <a16:creationId xmlns:a16="http://schemas.microsoft.com/office/drawing/2014/main" id="{9FCA61FE-480E-4906-61DD-69D737DFDE17}"/>
+                <a16:creationId xmlns:a16="http://schemas.microsoft.com/office/drawing/2014/main" id="{C6D7922B-2ADD-BE17-4999-8B67B77D098A}"/>
               </a:ext>
             </a:extLst>
           </p:cNvPr>
@@ -14637,8 +14651,8 @@
         </p:blipFill>
         <p:spPr>
           <a:xfrm>
-            <a:off x="6373698" y="2276480"/>
-            <a:ext cx="4684119" cy="4385571"/>
+            <a:off x="6765585" y="2355279"/>
+            <a:ext cx="4154342" cy="4264977"/>
           </a:xfrm>
           <a:prstGeom prst="rect">
             <a:avLst/>
@@ -14721,8 +14735,8 @@
         </p:nvSpPr>
         <p:spPr bwMode="auto">
           <a:xfrm>
-            <a:off x="581192" y="2687889"/>
-            <a:ext cx="11029616" cy="2343655"/>
+            <a:off x="581192" y="2457057"/>
+            <a:ext cx="11029616" cy="2805320"/>
           </a:xfrm>
           <a:prstGeom prst="rect">
             <a:avLst/>
@@ -14797,59 +14811,7 @@
                 <a:effectLst/>
                 <a:latin typeface="Arial" panose="020B0604020202020204" pitchFamily="34" charset="0"/>
               </a:rPr>
-              <a:t>El uso de </a:t>
-            </a:r>
-            <a:r>
-              <a:rPr kumimoji="0" lang="es-MX" altLang="es-MX" sz="2000" i="0" u="none" strike="noStrike" cap="none" normalizeH="0" baseline="0" dirty="0">
-                <a:ln>
-                  <a:noFill/>
-                </a:ln>
-                <a:solidFill>
-                  <a:schemeClr val="tx1"/>
-                </a:solidFill>
-                <a:effectLst/>
-                <a:latin typeface="Arial" panose="020B0604020202020204" pitchFamily="34" charset="0"/>
-              </a:rPr>
-              <a:t>Transfer </a:t>
-            </a:r>
-            <a:r>
-              <a:rPr kumimoji="0" lang="es-MX" altLang="es-MX" sz="2000" i="0" u="none" strike="noStrike" cap="none" normalizeH="0" baseline="0" dirty="0" err="1">
-                <a:ln>
-                  <a:noFill/>
-                </a:ln>
-                <a:solidFill>
-                  <a:schemeClr val="tx1"/>
-                </a:solidFill>
-                <a:effectLst/>
-                <a:latin typeface="Arial" panose="020B0604020202020204" pitchFamily="34" charset="0"/>
-              </a:rPr>
-              <a:t>Learning</a:t>
-            </a:r>
-            <a:r>
-              <a:rPr kumimoji="0" lang="es-MX" altLang="es-MX" sz="2000" i="0" u="none" strike="noStrike" cap="none" normalizeH="0" baseline="0" dirty="0">
-                <a:ln>
-                  <a:noFill/>
-                </a:ln>
-                <a:solidFill>
-                  <a:schemeClr val="tx1"/>
-                </a:solidFill>
-                <a:effectLst/>
-                <a:latin typeface="Arial" panose="020B0604020202020204" pitchFamily="34" charset="0"/>
-              </a:rPr>
-              <a:t> EfficientNetB0 </a:t>
-            </a:r>
-            <a:r>
-              <a:rPr kumimoji="0" lang="es-MX" altLang="es-MX" sz="2000" b="0" i="0" u="none" strike="noStrike" cap="none" normalizeH="0" baseline="0" dirty="0">
-                <a:ln>
-                  <a:noFill/>
-                </a:ln>
-                <a:solidFill>
-                  <a:schemeClr val="tx1"/>
-                </a:solidFill>
-                <a:effectLst/>
-                <a:latin typeface="Arial" panose="020B0604020202020204" pitchFamily="34" charset="0"/>
-              </a:rPr>
-              <a:t>superó ampliamente a los modelos tabulares y construidos desde cero.</a:t>
+              <a:t>El proyecto evidenció que los modelos base y las arquitecturas entrenadas desde cero tienen un rendimiento limitado para clasificación dermatológica multiclase.</a:t>
             </a:r>
           </a:p>
           <a:p>
@@ -14880,7 +14842,7 @@
                 <a:effectLst/>
                 <a:latin typeface="Arial" panose="020B0604020202020204" pitchFamily="34" charset="0"/>
               </a:rPr>
-              <a:t>La arquitectura propuesta es modular el </a:t>
+              <a:t>La mayor mejora se obtuvo con modelos </a:t>
             </a:r>
             <a:r>
               <a:rPr kumimoji="0" lang="es-MX" altLang="es-MX" sz="2000" b="0" i="0" u="none" strike="noStrike" cap="none" normalizeH="0" baseline="0" dirty="0" err="1">
@@ -14893,7 +14855,7 @@
                 <a:effectLst/>
                 <a:latin typeface="Arial" panose="020B0604020202020204" pitchFamily="34" charset="0"/>
               </a:rPr>
-              <a:t>Autoencoder</a:t>
+              <a:t>preentrenados</a:t>
             </a:r>
             <a:r>
               <a:rPr kumimoji="0" lang="es-MX" altLang="es-MX" sz="2000" b="0" i="0" u="none" strike="noStrike" cap="none" normalizeH="0" baseline="0" dirty="0">
@@ -14906,7 +14868,33 @@
                 <a:effectLst/>
                 <a:latin typeface="Arial" panose="020B0604020202020204" pitchFamily="34" charset="0"/>
               </a:rPr>
-              <a:t> limpia, la CNN clasifica.</a:t>
+              <a:t>, especialmente ViT-B16, confirmando la ventaja del transfer </a:t>
+            </a:r>
+            <a:r>
+              <a:rPr kumimoji="0" lang="es-MX" altLang="es-MX" sz="2000" b="0" i="0" u="none" strike="noStrike" cap="none" normalizeH="0" baseline="0" dirty="0" err="1">
+                <a:ln>
+                  <a:noFill/>
+                </a:ln>
+                <a:solidFill>
+                  <a:schemeClr val="tx1"/>
+                </a:solidFill>
+                <a:effectLst/>
+                <a:latin typeface="Arial" panose="020B0604020202020204" pitchFamily="34" charset="0"/>
+              </a:rPr>
+              <a:t>learning</a:t>
+            </a:r>
+            <a:r>
+              <a:rPr kumimoji="0" lang="es-MX" altLang="es-MX" sz="2000" b="0" i="0" u="none" strike="noStrike" cap="none" normalizeH="0" baseline="0" dirty="0">
+                <a:ln>
+                  <a:noFill/>
+                </a:ln>
+                <a:solidFill>
+                  <a:schemeClr val="tx1"/>
+                </a:solidFill>
+                <a:effectLst/>
+                <a:latin typeface="Arial" panose="020B0604020202020204" pitchFamily="34" charset="0"/>
+              </a:rPr>
+              <a:t> en problemas visuales complejos.</a:t>
             </a:r>
           </a:p>
           <a:p>
@@ -14937,7 +14925,59 @@
                 <a:effectLst/>
                 <a:latin typeface="Arial" panose="020B0604020202020204" pitchFamily="34" charset="0"/>
               </a:rPr>
-              <a:t>El proyecto está listo para evolucionar de un entorno de experimentación a un producto de software desplegable.</a:t>
+              <a:t>El aumento generativo no superó al </a:t>
+            </a:r>
+            <a:r>
+              <a:rPr kumimoji="0" lang="es-MX" altLang="es-MX" sz="2000" b="0" i="0" u="none" strike="noStrike" cap="none" normalizeH="0" baseline="0" dirty="0" err="1">
+                <a:ln>
+                  <a:noFill/>
+                </a:ln>
+                <a:solidFill>
+                  <a:schemeClr val="tx1"/>
+                </a:solidFill>
+                <a:effectLst/>
+                <a:latin typeface="Arial" panose="020B0604020202020204" pitchFamily="34" charset="0"/>
+              </a:rPr>
+              <a:t>baseline</a:t>
+            </a:r>
+            <a:r>
+              <a:rPr kumimoji="0" lang="es-MX" altLang="es-MX" sz="2000" b="0" i="0" u="none" strike="noStrike" cap="none" normalizeH="0" baseline="0" dirty="0">
+                <a:ln>
+                  <a:noFill/>
+                </a:ln>
+                <a:solidFill>
+                  <a:schemeClr val="tx1"/>
+                </a:solidFill>
+                <a:effectLst/>
+                <a:latin typeface="Arial" panose="020B0604020202020204" pitchFamily="34" charset="0"/>
+              </a:rPr>
+              <a:t>, por lo que la mejor solución final fue una arquitectura </a:t>
+            </a:r>
+            <a:r>
+              <a:rPr kumimoji="0" lang="es-MX" altLang="es-MX" sz="2000" b="0" i="0" u="none" strike="noStrike" cap="none" normalizeH="0" baseline="0" dirty="0" err="1">
+                <a:ln>
+                  <a:noFill/>
+                </a:ln>
+                <a:solidFill>
+                  <a:schemeClr val="tx1"/>
+                </a:solidFill>
+                <a:effectLst/>
+                <a:latin typeface="Arial" panose="020B0604020202020204" pitchFamily="34" charset="0"/>
+              </a:rPr>
+              <a:t>preentrenada</a:t>
+            </a:r>
+            <a:r>
+              <a:rPr kumimoji="0" lang="es-MX" altLang="es-MX" sz="2000" b="0" i="0" u="none" strike="noStrike" cap="none" normalizeH="0" baseline="0" dirty="0">
+                <a:ln>
+                  <a:noFill/>
+                </a:ln>
+                <a:solidFill>
+                  <a:schemeClr val="tx1"/>
+                </a:solidFill>
+                <a:effectLst/>
+                <a:latin typeface="Arial" panose="020B0604020202020204" pitchFamily="34" charset="0"/>
+              </a:rPr>
+              <a:t> optimizada para despliegue.</a:t>
             </a:r>
           </a:p>
         </p:txBody>
@@ -16072,7 +16112,7 @@
             <p:ph sz="half" idx="1"/>
             <p:extLst>
               <p:ext uri="{D42A27DB-BD31-4B8C-83A1-F6EECF244321}">
-                <p14:modId xmlns:p14="http://schemas.microsoft.com/office/powerpoint/2010/main" val="3078412532"/>
+                <p14:modId xmlns:p14="http://schemas.microsoft.com/office/powerpoint/2010/main" val="764162028"/>
               </p:ext>
             </p:extLst>
           </p:nvPr>
@@ -16161,38 +16201,6 @@
           </a:p>
         </p:txBody>
       </p:sp>
-      <p:pic>
-        <p:nvPicPr>
-          <p:cNvPr id="7" name="Marcador de contenido 6">
-            <a:extLst>
-              <a:ext uri="{FF2B5EF4-FFF2-40B4-BE49-F238E27FC236}">
-                <a16:creationId xmlns:a16="http://schemas.microsoft.com/office/drawing/2014/main" id="{9F833822-35F9-EB0C-D885-26557B35193C}"/>
-              </a:ext>
-            </a:extLst>
-          </p:cNvPr>
-          <p:cNvPicPr>
-            <a:picLocks noGrp="1" noChangeAspect="1"/>
-          </p:cNvPicPr>
-          <p:nvPr>
-            <p:ph sz="half" idx="2"/>
-          </p:nvPr>
-        </p:nvPicPr>
-        <p:blipFill>
-          <a:blip r:embed="rId2"/>
-          <a:stretch>
-            <a:fillRect/>
-          </a:stretch>
-        </p:blipFill>
-        <p:spPr>
-          <a:xfrm>
-            <a:off x="6449149" y="1890616"/>
-            <a:ext cx="5292025" cy="4636482"/>
-          </a:xfrm>
-          <a:prstGeom prst="rect">
-            <a:avLst/>
-          </a:prstGeom>
-        </p:spPr>
-      </p:pic>
       <p:sp>
         <p:nvSpPr>
           <p:cNvPr id="5" name="Rectangle 1">
@@ -16211,8 +16219,8 @@
         </p:nvSpPr>
         <p:spPr bwMode="auto">
           <a:xfrm>
-            <a:off x="450826" y="2411034"/>
-            <a:ext cx="5422392" cy="3266985"/>
+            <a:off x="443206" y="2073044"/>
+            <a:ext cx="5422392" cy="4478662"/>
           </a:xfrm>
           <a:prstGeom prst="rect">
             <a:avLst/>
@@ -16277,7 +16285,7 @@
               <a:tabLst/>
             </a:pPr>
             <a:r>
-              <a:rPr kumimoji="0" lang="es-MX" altLang="es-MX" sz="2000" b="1" i="0" u="none" strike="noStrike" cap="none" normalizeH="0" baseline="0" dirty="0">
+              <a:rPr kumimoji="0" lang="es-MX" altLang="es-MX" sz="1600" b="1" i="0" u="none" strike="noStrike" cap="none" normalizeH="0" baseline="0" dirty="0">
                 <a:ln>
                   <a:noFill/>
                 </a:ln>
@@ -16290,7 +16298,7 @@
               <a:t>Enfoque:</a:t>
             </a:r>
             <a:r>
-              <a:rPr kumimoji="0" lang="es-MX" altLang="es-MX" sz="2000" b="0" i="0" u="none" strike="noStrike" cap="none" normalizeH="0" baseline="0" dirty="0">
+              <a:rPr kumimoji="0" lang="es-MX" altLang="es-MX" sz="1600" b="0" i="0" u="none" strike="noStrike" cap="none" normalizeH="0" baseline="0" dirty="0">
                 <a:ln>
                   <a:noFill/>
                 </a:ln>
@@ -16300,7 +16308,33 @@
                 <a:effectLst/>
                 <a:latin typeface="Arial" panose="020B0604020202020204" pitchFamily="34" charset="0"/>
               </a:rPr>
-              <a:t> Uso exclusivo de características tabulares extraídas de la imagen como el tamaño, aspecto, canales RGB).</a:t>
+              <a:t> Uso de un MLP base como línea de referencia para clasificación multiclase de imágenes dermatológicas. Se trabajó con imágenes redimensionadas a 192×192, partición estratificada </a:t>
+            </a:r>
+            <a:r>
+              <a:rPr kumimoji="0" lang="es-MX" altLang="es-MX" sz="1600" b="0" i="0" u="none" strike="noStrike" cap="none" normalizeH="0" baseline="0" dirty="0" err="1">
+                <a:ln>
+                  <a:noFill/>
+                </a:ln>
+                <a:solidFill>
+                  <a:schemeClr val="tx1"/>
+                </a:solidFill>
+                <a:effectLst/>
+                <a:latin typeface="Arial" panose="020B0604020202020204" pitchFamily="34" charset="0"/>
+              </a:rPr>
+              <a:t>train</a:t>
+            </a:r>
+            <a:r>
+              <a:rPr kumimoji="0" lang="es-MX" altLang="es-MX" sz="1600" b="0" i="0" u="none" strike="noStrike" cap="none" normalizeH="0" baseline="0" dirty="0">
+                <a:ln>
+                  <a:noFill/>
+                </a:ln>
+                <a:solidFill>
+                  <a:schemeClr val="tx1"/>
+                </a:solidFill>
+                <a:effectLst/>
+                <a:latin typeface="Arial" panose="020B0604020202020204" pitchFamily="34" charset="0"/>
+              </a:rPr>
+              <a:t>/val/test, ponderación por clase para manejar desbalance y un pipeline de entrenamiento reproducible.</a:t>
             </a:r>
           </a:p>
           <a:p>
@@ -16321,7 +16355,7 @@
               <a:tabLst/>
             </a:pPr>
             <a:r>
-              <a:rPr kumimoji="0" lang="es-MX" altLang="es-MX" sz="2000" b="1" i="0" u="none" strike="noStrike" cap="none" normalizeH="0" baseline="0" dirty="0">
+              <a:rPr kumimoji="0" lang="es-MX" altLang="es-MX" sz="1600" b="1" i="0" u="none" strike="noStrike" cap="none" normalizeH="0" baseline="0" dirty="0">
                 <a:ln>
                   <a:noFill/>
                 </a:ln>
@@ -16331,24 +16365,70 @@
                 <a:effectLst/>
                 <a:latin typeface="Arial" panose="020B0604020202020204" pitchFamily="34" charset="0"/>
               </a:rPr>
-              <a:t>Resultados:</a:t>
+              <a:t>Resultados: </a:t>
             </a:r>
             <a:r>
-              <a:rPr kumimoji="0" lang="es-MX" altLang="es-MX" sz="2000" b="0" i="0" u="none" strike="noStrike" cap="none" normalizeH="0" baseline="0" dirty="0">
-                <a:ln>
-                  <a:noFill/>
-                </a:ln>
+              <a:rPr lang="es-MX" altLang="es-MX" sz="1600" dirty="0">
                 <a:solidFill>
                   <a:schemeClr val="tx1"/>
                 </a:solidFill>
-                <a:effectLst/>
                 <a:latin typeface="Arial" panose="020B0604020202020204" pitchFamily="34" charset="0"/>
               </a:rPr>
-              <a:t> Rendimiento limitado. El modelo no logró capturar la complejidad espacial de las lesiones, funcionando solo como línea base comparativa.</a:t>
+              <a:t>El modelo alcanzó un </a:t>
+            </a:r>
+            <a:r>
+              <a:rPr lang="es-MX" altLang="es-MX" sz="1600" dirty="0" err="1">
+                <a:solidFill>
+                  <a:schemeClr val="tx1"/>
+                </a:solidFill>
+                <a:latin typeface="Arial" panose="020B0604020202020204" pitchFamily="34" charset="0"/>
+              </a:rPr>
+              <a:t>accuracy</a:t>
+            </a:r>
+            <a:r>
+              <a:rPr lang="es-MX" altLang="es-MX" sz="1600" dirty="0">
+                <a:solidFill>
+                  <a:schemeClr val="tx1"/>
+                </a:solidFill>
+                <a:latin typeface="Arial" panose="020B0604020202020204" pitchFamily="34" charset="0"/>
+              </a:rPr>
+              <a:t> de 0.2618 y un macro F1 de 0.2152, por debajo de la meta de referencia. Su aporte principal fue establecer una línea base metodológica y comparativa para medir la mejora obtenida con arquitecturas más avanzadas en etapas posteriores.</a:t>
             </a:r>
           </a:p>
         </p:txBody>
       </p:sp>
+      <p:pic>
+        <p:nvPicPr>
+          <p:cNvPr id="8" name="Marcador de contenido 7">
+            <a:extLst>
+              <a:ext uri="{FF2B5EF4-FFF2-40B4-BE49-F238E27FC236}">
+                <a16:creationId xmlns:a16="http://schemas.microsoft.com/office/drawing/2014/main" id="{72BD3874-8632-ABCC-890B-455263954C26}"/>
+              </a:ext>
+            </a:extLst>
+          </p:cNvPr>
+          <p:cNvPicPr>
+            <a:picLocks noGrp="1" noChangeAspect="1"/>
+          </p:cNvPicPr>
+          <p:nvPr>
+            <p:ph sz="half" idx="2"/>
+          </p:nvPr>
+        </p:nvPicPr>
+        <p:blipFill>
+          <a:blip r:embed="rId2"/>
+          <a:stretch>
+            <a:fillRect/>
+          </a:stretch>
+        </p:blipFill>
+        <p:spPr>
+          <a:xfrm>
+            <a:off x="6187909" y="2496409"/>
+            <a:ext cx="5422900" cy="3631933"/>
+          </a:xfrm>
+          <a:prstGeom prst="rect">
+            <a:avLst/>
+          </a:prstGeom>
+        </p:spPr>
+      </p:pic>
     </p:spTree>
     <p:extLst>
       <p:ext uri="{BB962C8B-B14F-4D97-AF65-F5344CB8AC3E}">
@@ -16401,44 +16481,13 @@
           <a:lstStyle/>
           <a:p>
             <a:r>
-              <a:rPr lang="es-MX" dirty="0"/>
-              <a:t>Etapa 2: Exploración de CNN y Secuencias</a:t>
+              <a:rPr lang="pt-BR" dirty="0"/>
+              <a:t>ETAPA 2: ARQUITECTURA PROFUNDA ESPECIALIZADA</a:t>
             </a:r>
+            <a:endParaRPr lang="es-MX" dirty="0"/>
           </a:p>
         </p:txBody>
       </p:sp>
-      <p:pic>
-        <p:nvPicPr>
-          <p:cNvPr id="7" name="Marcador de contenido 6">
-            <a:extLst>
-              <a:ext uri="{FF2B5EF4-FFF2-40B4-BE49-F238E27FC236}">
-                <a16:creationId xmlns:a16="http://schemas.microsoft.com/office/drawing/2014/main" id="{3F66249B-87BD-B9C4-DB18-B209085ECF33}"/>
-              </a:ext>
-            </a:extLst>
-          </p:cNvPr>
-          <p:cNvPicPr>
-            <a:picLocks noGrp="1" noChangeAspect="1"/>
-          </p:cNvPicPr>
-          <p:nvPr>
-            <p:ph sz="half" idx="2"/>
-          </p:nvPr>
-        </p:nvPicPr>
-        <p:blipFill>
-          <a:blip r:embed="rId2"/>
-          <a:stretch>
-            <a:fillRect/>
-          </a:stretch>
-        </p:blipFill>
-        <p:spPr>
-          <a:xfrm>
-            <a:off x="5117839" y="1915886"/>
-            <a:ext cx="6899990" cy="4418914"/>
-          </a:xfrm>
-          <a:prstGeom prst="rect">
-            <a:avLst/>
-          </a:prstGeom>
-        </p:spPr>
-      </p:pic>
       <p:sp>
         <p:nvSpPr>
           <p:cNvPr id="5" name="Rectangle 1">
@@ -16457,8 +16506,8 @@
         </p:nvSpPr>
         <p:spPr bwMode="auto">
           <a:xfrm>
-            <a:off x="436470" y="1718537"/>
-            <a:ext cx="4701587" cy="4651979"/>
+            <a:off x="308835" y="2122488"/>
+            <a:ext cx="5110890" cy="4611519"/>
           </a:xfrm>
           <a:prstGeom prst="rect">
             <a:avLst/>
@@ -16523,7 +16572,7 @@
               <a:tabLst/>
             </a:pPr>
             <a:r>
-              <a:rPr kumimoji="0" lang="es-MX" altLang="es-MX" sz="2000" b="1" i="0" u="none" strike="noStrike" cap="none" normalizeH="0" baseline="0" dirty="0">
+              <a:rPr kumimoji="0" lang="es-MX" altLang="es-MX" b="1" i="0" u="none" strike="noStrike" cap="none" normalizeH="0" baseline="0" dirty="0">
                 <a:ln>
                   <a:noFill/>
                 </a:ln>
@@ -16536,7 +16585,7 @@
               <a:t>Enfoque:</a:t>
             </a:r>
             <a:r>
-              <a:rPr kumimoji="0" lang="es-MX" altLang="es-MX" sz="2000" b="0" i="0" u="none" strike="noStrike" cap="none" normalizeH="0" baseline="0" dirty="0">
+              <a:rPr kumimoji="0" lang="es-MX" altLang="es-MX" b="0" i="0" u="none" strike="noStrike" cap="none" normalizeH="0" baseline="0" dirty="0">
                 <a:ln>
                   <a:noFill/>
                 </a:ln>
@@ -16546,33 +16595,7 @@
                 <a:effectLst/>
                 <a:latin typeface="Arial" panose="020B0604020202020204" pitchFamily="34" charset="0"/>
               </a:rPr>
-              <a:t> Implementación de </a:t>
-            </a:r>
-            <a:r>
-              <a:rPr kumimoji="0" lang="es-MX" altLang="es-MX" sz="2000" b="0" i="0" u="none" strike="noStrike" cap="none" normalizeH="0" baseline="0" dirty="0" err="1">
-                <a:ln>
-                  <a:noFill/>
-                </a:ln>
-                <a:solidFill>
-                  <a:schemeClr val="tx1"/>
-                </a:solidFill>
-                <a:effectLst/>
-                <a:latin typeface="Arial" panose="020B0604020202020204" pitchFamily="34" charset="0"/>
-              </a:rPr>
-              <a:t>CNNs</a:t>
-            </a:r>
-            <a:r>
-              <a:rPr kumimoji="0" lang="es-MX" altLang="es-MX" sz="2000" b="0" i="0" u="none" strike="noStrike" cap="none" normalizeH="0" baseline="0" dirty="0">
-                <a:ln>
-                  <a:noFill/>
-                </a:ln>
-                <a:solidFill>
-                  <a:schemeClr val="tx1"/>
-                </a:solidFill>
-                <a:effectLst/>
-                <a:latin typeface="Arial" panose="020B0604020202020204" pitchFamily="34" charset="0"/>
-              </a:rPr>
-              <a:t> construidas desde cero y pruebas con arquitecturas recurrentes (LSTM/GRU) tratando los píxeles como secuencias.</a:t>
+              <a:t> Se implementó una CNN profunda entrenada desde cero para clasificación multiclase de imágenes dermatológicas, usando imágenes de 224×224, partición estratificada y ponderación por clase.</a:t>
             </a:r>
           </a:p>
           <a:p>
@@ -16593,7 +16616,7 @@
               <a:tabLst/>
             </a:pPr>
             <a:r>
-              <a:rPr kumimoji="0" lang="es-MX" altLang="es-MX" sz="2000" b="1" i="0" u="none" strike="noStrike" cap="none" normalizeH="0" baseline="0" dirty="0">
+              <a:rPr kumimoji="0" lang="es-MX" altLang="es-MX" b="1" i="0" u="none" strike="noStrike" cap="none" normalizeH="0" baseline="0" dirty="0">
                 <a:ln>
                   <a:noFill/>
                 </a:ln>
@@ -16606,7 +16629,7 @@
               <a:t>Resultados:</a:t>
             </a:r>
             <a:r>
-              <a:rPr kumimoji="0" lang="es-MX" altLang="es-MX" sz="2000" b="0" i="0" u="none" strike="noStrike" cap="none" normalizeH="0" baseline="0" dirty="0">
+              <a:rPr kumimoji="0" lang="es-MX" altLang="es-MX" b="0" i="0" u="none" strike="noStrike" cap="none" normalizeH="0" baseline="0" dirty="0">
                 <a:ln>
                   <a:noFill/>
                 </a:ln>
@@ -16616,11 +16639,121 @@
                 <a:effectLst/>
                 <a:latin typeface="Arial" panose="020B0604020202020204" pitchFamily="34" charset="0"/>
               </a:rPr>
-              <a:t> Mejora significativa respecto al modelo base en la detección de bordes y texturas de las lesiones. Sin embargo, limitados por la cantidad de datos para entrenar desde cero sin sobreajuste.</a:t>
+              <a:t> El modelo superó al </a:t>
+            </a:r>
+            <a:r>
+              <a:rPr kumimoji="0" lang="es-MX" altLang="es-MX" b="0" i="0" u="none" strike="noStrike" cap="none" normalizeH="0" baseline="0" dirty="0" err="1">
+                <a:ln>
+                  <a:noFill/>
+                </a:ln>
+                <a:solidFill>
+                  <a:schemeClr val="tx1"/>
+                </a:solidFill>
+                <a:effectLst/>
+                <a:latin typeface="Arial" panose="020B0604020202020204" pitchFamily="34" charset="0"/>
+              </a:rPr>
+              <a:t>baseline</a:t>
+            </a:r>
+            <a:r>
+              <a:rPr kumimoji="0" lang="es-MX" altLang="es-MX" b="0" i="0" u="none" strike="noStrike" cap="none" normalizeH="0" baseline="0" dirty="0">
+                <a:ln>
+                  <a:noFill/>
+                </a:ln>
+                <a:solidFill>
+                  <a:schemeClr val="tx1"/>
+                </a:solidFill>
+                <a:effectLst/>
+                <a:latin typeface="Arial" panose="020B0604020202020204" pitchFamily="34" charset="0"/>
+              </a:rPr>
+              <a:t> de Etapa 1 y alcanzó un </a:t>
+            </a:r>
+            <a:r>
+              <a:rPr kumimoji="0" lang="es-MX" altLang="es-MX" b="0" i="0" u="none" strike="noStrike" cap="none" normalizeH="0" baseline="0" dirty="0" err="1">
+                <a:ln>
+                  <a:noFill/>
+                </a:ln>
+                <a:solidFill>
+                  <a:schemeClr val="tx1"/>
+                </a:solidFill>
+                <a:effectLst/>
+                <a:latin typeface="Arial" panose="020B0604020202020204" pitchFamily="34" charset="0"/>
+              </a:rPr>
+              <a:t>accuracy</a:t>
+            </a:r>
+            <a:r>
+              <a:rPr kumimoji="0" lang="es-MX" altLang="es-MX" b="0" i="0" u="none" strike="noStrike" cap="none" normalizeH="0" baseline="0" dirty="0">
+                <a:ln>
+                  <a:noFill/>
+                </a:ln>
+                <a:solidFill>
+                  <a:schemeClr val="tx1"/>
+                </a:solidFill>
+                <a:effectLst/>
+                <a:latin typeface="Arial" panose="020B0604020202020204" pitchFamily="34" charset="0"/>
+              </a:rPr>
+              <a:t> de 0.3957 y macro F1 de 0.3828. Aunque mostró una mejora clara, no alcanzó la meta de 0.60, lo que motivó el uso de modelos </a:t>
+            </a:r>
+            <a:r>
+              <a:rPr kumimoji="0" lang="es-MX" altLang="es-MX" b="0" i="0" u="none" strike="noStrike" cap="none" normalizeH="0" baseline="0" dirty="0" err="1">
+                <a:ln>
+                  <a:noFill/>
+                </a:ln>
+                <a:solidFill>
+                  <a:schemeClr val="tx1"/>
+                </a:solidFill>
+                <a:effectLst/>
+                <a:latin typeface="Arial" panose="020B0604020202020204" pitchFamily="34" charset="0"/>
+              </a:rPr>
+              <a:t>preentrenados</a:t>
+            </a:r>
+            <a:r>
+              <a:rPr kumimoji="0" lang="es-MX" altLang="es-MX" b="0" i="0" u="none" strike="noStrike" cap="none" normalizeH="0" baseline="0" dirty="0">
+                <a:ln>
+                  <a:noFill/>
+                </a:ln>
+                <a:solidFill>
+                  <a:schemeClr val="tx1"/>
+                </a:solidFill>
+                <a:effectLst/>
+                <a:latin typeface="Arial" panose="020B0604020202020204" pitchFamily="34" charset="0"/>
+              </a:rPr>
+              <a:t> en la siguiente etapa.</a:t>
             </a:r>
           </a:p>
         </p:txBody>
       </p:sp>
+      <p:pic>
+        <p:nvPicPr>
+          <p:cNvPr id="8" name="Marcador de contenido 7">
+            <a:extLst>
+              <a:ext uri="{FF2B5EF4-FFF2-40B4-BE49-F238E27FC236}">
+                <a16:creationId xmlns:a16="http://schemas.microsoft.com/office/drawing/2014/main" id="{BCE7E22E-85C5-9FEE-44BA-C328E6E3C10A}"/>
+              </a:ext>
+            </a:extLst>
+          </p:cNvPr>
+          <p:cNvPicPr>
+            <a:picLocks noGrp="1" noChangeAspect="1"/>
+          </p:cNvPicPr>
+          <p:nvPr>
+            <p:ph sz="half" idx="2"/>
+          </p:nvPr>
+        </p:nvPicPr>
+        <p:blipFill>
+          <a:blip r:embed="rId2"/>
+          <a:stretch>
+            <a:fillRect/>
+          </a:stretch>
+        </p:blipFill>
+        <p:spPr>
+          <a:xfrm>
+            <a:off x="5580566" y="2122488"/>
+            <a:ext cx="6135184" cy="4459131"/>
+          </a:xfrm>
+          <a:prstGeom prst="rect">
+            <a:avLst/>
+          </a:prstGeom>
+        </p:spPr>
+      </p:pic>
     </p:spTree>
     <p:extLst>
       <p:ext uri="{BB962C8B-B14F-4D97-AF65-F5344CB8AC3E}">
@@ -16673,45 +16806,12 @@
           <a:lstStyle/>
           <a:p>
             <a:r>
-              <a:rPr lang="en-US" dirty="0"/>
-              <a:t>Etapa 3: EfficientNetB0 - Transfer Learning</a:t>
+              <a:rPr lang="es-MX" dirty="0"/>
+              <a:t>ETAPA 3: MODELOS PREENTRENADOS Y TRANSFORMERS</a:t>
             </a:r>
-            <a:endParaRPr lang="es-MX" dirty="0"/>
           </a:p>
         </p:txBody>
       </p:sp>
-      <p:pic>
-        <p:nvPicPr>
-          <p:cNvPr id="7" name="Marcador de contenido 6">
-            <a:extLst>
-              <a:ext uri="{FF2B5EF4-FFF2-40B4-BE49-F238E27FC236}">
-                <a16:creationId xmlns:a16="http://schemas.microsoft.com/office/drawing/2014/main" id="{2E228EC9-7F9E-3BDA-E030-479091E321FE}"/>
-              </a:ext>
-            </a:extLst>
-          </p:cNvPr>
-          <p:cNvPicPr>
-            <a:picLocks noGrp="1" noChangeAspect="1"/>
-          </p:cNvPicPr>
-          <p:nvPr>
-            <p:ph sz="half" idx="2"/>
-          </p:nvPr>
-        </p:nvPicPr>
-        <p:blipFill>
-          <a:blip r:embed="rId2"/>
-          <a:stretch>
-            <a:fillRect/>
-          </a:stretch>
-        </p:blipFill>
-        <p:spPr>
-          <a:xfrm>
-            <a:off x="4916028" y="2090057"/>
-            <a:ext cx="6694947" cy="4376609"/>
-          </a:xfrm>
-          <a:prstGeom prst="rect">
-            <a:avLst/>
-          </a:prstGeom>
-        </p:spPr>
-      </p:pic>
       <p:sp>
         <p:nvSpPr>
           <p:cNvPr id="5" name="Rectangle 1">
@@ -16730,8 +16830,8 @@
         </p:nvSpPr>
         <p:spPr bwMode="auto">
           <a:xfrm rot="10800000" flipV="1">
-            <a:off x="454046" y="1933984"/>
-            <a:ext cx="4461982" cy="4651979"/>
+            <a:off x="454046" y="1954214"/>
+            <a:ext cx="4461982" cy="4611519"/>
           </a:xfrm>
           <a:prstGeom prst="rect">
             <a:avLst/>
@@ -16779,7 +16879,7 @@
           </a:bodyPr>
           <a:lstStyle/>
           <a:p>
-            <a:pPr marL="0" marR="0" lvl="0" indent="0" algn="just" defTabSz="914400" rtl="0" eaLnBrk="0" fontAlgn="base" latinLnBrk="0" hangingPunct="0">
+            <a:pPr marL="0" marR="0" lvl="0" indent="0" defTabSz="914400" rtl="0" eaLnBrk="0" fontAlgn="base" latinLnBrk="0" hangingPunct="0">
               <a:lnSpc>
                 <a:spcPct val="150000"/>
               </a:lnSpc>
@@ -16796,7 +16896,7 @@
               <a:tabLst/>
             </a:pPr>
             <a:r>
-              <a:rPr kumimoji="0" lang="es-MX" altLang="es-MX" sz="2000" b="1" i="0" u="none" strike="noStrike" cap="none" normalizeH="0" baseline="0" dirty="0">
+              <a:rPr kumimoji="0" lang="es-MX" altLang="es-MX" b="1" i="0" u="none" strike="noStrike" cap="none" normalizeH="0" baseline="0" dirty="0">
                 <a:ln>
                   <a:noFill/>
                 </a:ln>
@@ -16809,7 +16909,7 @@
               <a:t>Enfoque:</a:t>
             </a:r>
             <a:r>
-              <a:rPr kumimoji="0" lang="es-MX" altLang="es-MX" sz="2000" b="0" i="0" u="none" strike="noStrike" cap="none" normalizeH="0" baseline="0" dirty="0">
+              <a:rPr kumimoji="0" lang="es-MX" altLang="es-MX" b="0" i="0" u="none" strike="noStrike" cap="none" normalizeH="0" baseline="0" dirty="0">
                 <a:ln>
                   <a:noFill/>
                 </a:ln>
@@ -16819,10 +16919,10 @@
                 <a:effectLst/>
                 <a:latin typeface="Arial" panose="020B0604020202020204" pitchFamily="34" charset="0"/>
               </a:rPr>
-              <a:t> Uso de un modelo </a:t>
+              <a:t> Se compararon dos arquitecturas </a:t>
             </a:r>
             <a:r>
-              <a:rPr kumimoji="0" lang="es-MX" altLang="es-MX" sz="2000" b="0" i="0" u="none" strike="noStrike" cap="none" normalizeH="0" baseline="0" dirty="0" err="1">
+              <a:rPr kumimoji="0" lang="es-MX" altLang="es-MX" b="0" i="0" u="none" strike="noStrike" cap="none" normalizeH="0" baseline="0" dirty="0" err="1">
                 <a:ln>
                   <a:noFill/>
                 </a:ln>
@@ -16832,10 +16932,10 @@
                 <a:effectLst/>
                 <a:latin typeface="Arial" panose="020B0604020202020204" pitchFamily="34" charset="0"/>
               </a:rPr>
-              <a:t>preentrenado</a:t>
+              <a:t>preentrenadas</a:t>
             </a:r>
             <a:r>
-              <a:rPr kumimoji="0" lang="es-MX" altLang="es-MX" sz="2000" b="0" i="0" u="none" strike="noStrike" cap="none" normalizeH="0" baseline="0" dirty="0">
+              <a:rPr kumimoji="0" lang="es-MX" altLang="es-MX" b="0" i="0" u="none" strike="noStrike" cap="none" normalizeH="0" baseline="0" dirty="0">
                 <a:ln>
                   <a:noFill/>
                 </a:ln>
@@ -16845,76 +16945,11 @@
                 <a:effectLst/>
                 <a:latin typeface="Arial" panose="020B0604020202020204" pitchFamily="34" charset="0"/>
               </a:rPr>
-              <a:t> con </a:t>
-            </a:r>
-            <a:r>
-              <a:rPr kumimoji="0" lang="es-MX" altLang="es-MX" sz="2000" b="0" i="0" u="none" strike="noStrike" cap="none" normalizeH="0" baseline="0" dirty="0" err="1">
-                <a:ln>
-                  <a:noFill/>
-                </a:ln>
-                <a:solidFill>
-                  <a:schemeClr val="tx1"/>
-                </a:solidFill>
-                <a:effectLst/>
-                <a:latin typeface="Arial" panose="020B0604020202020204" pitchFamily="34" charset="0"/>
-              </a:rPr>
-              <a:t>ImageNet</a:t>
-            </a:r>
-            <a:r>
-              <a:rPr kumimoji="0" lang="es-MX" altLang="es-MX" sz="2000" b="0" i="0" u="none" strike="noStrike" cap="none" normalizeH="0" baseline="0" dirty="0">
-                <a:ln>
-                  <a:noFill/>
-                </a:ln>
-                <a:solidFill>
-                  <a:schemeClr val="tx1"/>
-                </a:solidFill>
-                <a:effectLst/>
-                <a:latin typeface="Arial" panose="020B0604020202020204" pitchFamily="34" charset="0"/>
-              </a:rPr>
-              <a:t> y </a:t>
-            </a:r>
-            <a:r>
-              <a:rPr kumimoji="0" lang="es-MX" altLang="es-MX" sz="2000" b="0" i="1" u="none" strike="noStrike" cap="none" normalizeH="0" baseline="0" dirty="0">
-                <a:ln>
-                  <a:noFill/>
-                </a:ln>
-                <a:solidFill>
-                  <a:schemeClr val="tx1"/>
-                </a:solidFill>
-                <a:effectLst/>
-                <a:latin typeface="Arial" panose="020B0604020202020204" pitchFamily="34" charset="0"/>
-              </a:rPr>
-              <a:t>fine-</a:t>
-            </a:r>
-            <a:r>
-              <a:rPr kumimoji="0" lang="es-MX" altLang="es-MX" sz="2000" b="0" i="1" u="none" strike="noStrike" cap="none" normalizeH="0" baseline="0" dirty="0" err="1">
-                <a:ln>
-                  <a:noFill/>
-                </a:ln>
-                <a:solidFill>
-                  <a:schemeClr val="tx1"/>
-                </a:solidFill>
-                <a:effectLst/>
-                <a:latin typeface="Arial" panose="020B0604020202020204" pitchFamily="34" charset="0"/>
-              </a:rPr>
-              <a:t>tuning</a:t>
-            </a:r>
-            <a:r>
-              <a:rPr kumimoji="0" lang="es-MX" altLang="es-MX" sz="2000" b="0" i="0" u="none" strike="noStrike" cap="none" normalizeH="0" baseline="0" dirty="0">
-                <a:ln>
-                  <a:noFill/>
-                </a:ln>
-                <a:solidFill>
-                  <a:schemeClr val="tx1"/>
-                </a:solidFill>
-                <a:effectLst/>
-                <a:latin typeface="Arial" panose="020B0604020202020204" pitchFamily="34" charset="0"/>
-              </a:rPr>
-              <a:t> de las últimas capas para el dominio dermatológico.</a:t>
+              <a:t>, EfficientNetB0 y ViT-B16, usando el mismo protocolo experimental y las mismas métricas de evaluación.</a:t>
             </a:r>
           </a:p>
           <a:p>
-            <a:pPr marL="0" marR="0" lvl="0" indent="0" algn="just" defTabSz="914400" rtl="0" eaLnBrk="0" fontAlgn="base" latinLnBrk="0" hangingPunct="0">
+            <a:pPr marL="0" marR="0" lvl="0" indent="0" defTabSz="914400" rtl="0" eaLnBrk="0" fontAlgn="base" latinLnBrk="0" hangingPunct="0">
               <a:lnSpc>
                 <a:spcPct val="150000"/>
               </a:lnSpc>
@@ -16931,7 +16966,7 @@
               <a:tabLst/>
             </a:pPr>
             <a:r>
-              <a:rPr kumimoji="0" lang="es-MX" altLang="es-MX" sz="2000" b="1" i="0" u="none" strike="noStrike" cap="none" normalizeH="0" baseline="0" dirty="0">
+              <a:rPr kumimoji="0" lang="es-MX" altLang="es-MX" b="1" i="0" u="none" strike="noStrike" cap="none" normalizeH="0" baseline="0" dirty="0">
                 <a:ln>
                   <a:noFill/>
                 </a:ln>
@@ -16944,7 +16979,7 @@
               <a:t>Resultados:</a:t>
             </a:r>
             <a:r>
-              <a:rPr kumimoji="0" lang="es-MX" altLang="es-MX" sz="2000" b="0" i="0" u="none" strike="noStrike" cap="none" normalizeH="0" baseline="0" dirty="0">
+              <a:rPr kumimoji="0" lang="es-MX" altLang="es-MX" b="0" i="0" u="none" strike="noStrike" cap="none" normalizeH="0" baseline="0" dirty="0">
                 <a:ln>
                   <a:noFill/>
                 </a:ln>
@@ -16954,10 +16989,10 @@
                 <a:effectLst/>
                 <a:latin typeface="Arial" panose="020B0604020202020204" pitchFamily="34" charset="0"/>
               </a:rPr>
-              <a:t> La mejor arquitectura del proyecto. Logró alta capacidad de generalización, estabilización rápida de la pérdida (</a:t>
+              <a:t> La etapa mostró una mejora sustancial frente a las anteriores. El mejor modelo fue ViT-B16, con </a:t>
             </a:r>
             <a:r>
-              <a:rPr kumimoji="0" lang="es-MX" altLang="es-MX" sz="2000" b="0" i="0" u="none" strike="noStrike" cap="none" normalizeH="0" baseline="0" dirty="0" err="1">
+              <a:rPr kumimoji="0" lang="es-MX" altLang="es-MX" b="0" i="0" u="none" strike="noStrike" cap="none" normalizeH="0" baseline="0" dirty="0" err="1">
                 <a:ln>
                   <a:noFill/>
                 </a:ln>
@@ -16967,10 +17002,10 @@
                 <a:effectLst/>
                 <a:latin typeface="Arial" panose="020B0604020202020204" pitchFamily="34" charset="0"/>
               </a:rPr>
-              <a:t>Loss</a:t>
+              <a:t>accuracy</a:t>
             </a:r>
             <a:r>
-              <a:rPr kumimoji="0" lang="es-MX" altLang="es-MX" sz="2000" b="0" i="0" u="none" strike="noStrike" cap="none" normalizeH="0" baseline="0" dirty="0">
+              <a:rPr kumimoji="0" lang="es-MX" altLang="es-MX" b="0" i="0" u="none" strike="noStrike" cap="none" normalizeH="0" baseline="0" dirty="0">
                 <a:ln>
                   <a:noFill/>
                 </a:ln>
@@ -16980,37 +17015,73 @@
                 <a:effectLst/>
                 <a:latin typeface="Arial" panose="020B0604020202020204" pitchFamily="34" charset="0"/>
               </a:rPr>
-              <a:t>) y las mejores métricas de precisión </a:t>
-            </a:r>
-            <a:r>
-              <a:rPr kumimoji="0" lang="es-MX" altLang="es-MX" sz="2000" b="0" i="0" u="none" strike="noStrike" cap="none" normalizeH="0" baseline="0" dirty="0" err="1">
-                <a:ln>
-                  <a:noFill/>
-                </a:ln>
-                <a:solidFill>
-                  <a:schemeClr val="tx1"/>
-                </a:solidFill>
-                <a:effectLst/>
-                <a:latin typeface="Arial" panose="020B0604020202020204" pitchFamily="34" charset="0"/>
-              </a:rPr>
-              <a:t>Accuracy</a:t>
-            </a:r>
-            <a:r>
-              <a:rPr kumimoji="0" lang="es-MX" altLang="es-MX" sz="2000" b="0" i="0" u="none" strike="noStrike" cap="none" normalizeH="0" baseline="0" dirty="0">
-                <a:ln>
-                  <a:noFill/>
-                </a:ln>
-                <a:solidFill>
-                  <a:schemeClr val="tx1"/>
-                </a:solidFill>
-                <a:effectLst/>
-                <a:latin typeface="Arial" panose="020B0604020202020204" pitchFamily="34" charset="0"/>
-              </a:rPr>
-              <a:t>/F1-Score.</a:t>
+              <a:t> ≈ 0.58 y macro F1 ≈ 0.57, superando claramente a la CNN entrenada desde cero.</a:t>
             </a:r>
           </a:p>
         </p:txBody>
       </p:sp>
+      <p:pic>
+        <p:nvPicPr>
+          <p:cNvPr id="10" name="Marcador de contenido 9">
+            <a:extLst>
+              <a:ext uri="{FF2B5EF4-FFF2-40B4-BE49-F238E27FC236}">
+                <a16:creationId xmlns:a16="http://schemas.microsoft.com/office/drawing/2014/main" id="{F3841BA5-499C-C979-09F0-CFEC9FFF5D88}"/>
+              </a:ext>
+            </a:extLst>
+          </p:cNvPr>
+          <p:cNvPicPr>
+            <a:picLocks noGrp="1" noChangeAspect="1"/>
+          </p:cNvPicPr>
+          <p:nvPr>
+            <p:ph sz="half" idx="2"/>
+          </p:nvPr>
+        </p:nvPicPr>
+        <p:blipFill>
+          <a:blip r:embed="rId2"/>
+          <a:stretch>
+            <a:fillRect/>
+          </a:stretch>
+        </p:blipFill>
+        <p:spPr>
+          <a:xfrm>
+            <a:off x="5006975" y="4633815"/>
+            <a:ext cx="6988244" cy="1952671"/>
+          </a:xfrm>
+          <a:prstGeom prst="rect">
+            <a:avLst/>
+          </a:prstGeom>
+        </p:spPr>
+      </p:pic>
+      <p:pic>
+        <p:nvPicPr>
+          <p:cNvPr id="13" name="Imagen 12">
+            <a:extLst>
+              <a:ext uri="{FF2B5EF4-FFF2-40B4-BE49-F238E27FC236}">
+                <a16:creationId xmlns:a16="http://schemas.microsoft.com/office/drawing/2014/main" id="{61979A97-9CDD-4670-4DE6-DF752335BFB3}"/>
+              </a:ext>
+            </a:extLst>
+          </p:cNvPr>
+          <p:cNvPicPr>
+            <a:picLocks noChangeAspect="1"/>
+          </p:cNvPicPr>
+          <p:nvPr/>
+        </p:nvPicPr>
+        <p:blipFill>
+          <a:blip r:embed="rId3"/>
+          <a:stretch>
+            <a:fillRect/>
+          </a:stretch>
+        </p:blipFill>
+        <p:spPr>
+          <a:xfrm>
+            <a:off x="5509493" y="1954214"/>
+            <a:ext cx="5501408" cy="2443377"/>
+          </a:xfrm>
+          <a:prstGeom prst="rect">
+            <a:avLst/>
+          </a:prstGeom>
+        </p:spPr>
+      </p:pic>
     </p:spTree>
     <p:extLst>
       <p:ext uri="{BB962C8B-B14F-4D97-AF65-F5344CB8AC3E}">

</xml_diff>